<commit_message>
feat: embed photo of AWS architecture diagram across report, slides, and web deck
</commit_message>
<xml_diff>
--- a/docs/presentation/executive_presentation.pptx
+++ b/docs/presentation/executive_presentation.pptx
@@ -8426,306 +8426,30 @@
           </a:p>
         </p:txBody>
       </p:sp>
-      <p:sp>
-        <p:nvSpPr>
-          <p:cNvPr id="5" name="Rounded Rectangle 4"/>
-          <p:cNvSpPr/>
-          <p:nvPr/>
-        </p:nvSpPr>
-        <p:spPr>
-          <a:xfrm>
-            <a:off x="914400" y="2286000"/>
-            <a:ext cx="3246120" cy="3840480"/>
-          </a:xfrm>
-          <a:prstGeom prst="roundRect">
-            <a:avLst/>
-          </a:prstGeom>
-          <a:solidFill>
-            <a:srgbClr val="161E31"/>
-          </a:solidFill>
-          <a:ln w="15240">
-            <a:solidFill>
-              <a:srgbClr val="38BDF8"/>
-            </a:solidFill>
-          </a:ln>
-        </p:spPr>
-        <p:style>
-          <a:lnRef idx="1">
-            <a:schemeClr val="accent1"/>
-          </a:lnRef>
-          <a:fillRef idx="3">
-            <a:schemeClr val="accent1"/>
-          </a:fillRef>
-          <a:effectRef idx="2">
-            <a:schemeClr val="accent1"/>
-          </a:effectRef>
-          <a:fontRef idx="minor">
-            <a:schemeClr val="lt1"/>
-          </a:fontRef>
-        </p:style>
-        <p:txBody>
-          <a:bodyPr rtlCol="0" anchor="ctr"/>
-          <a:lstStyle/>
-          <a:p>
-            <a:pPr algn="ctr"/>
-          </a:p>
-        </p:txBody>
-      </p:sp>
-      <p:sp>
-        <p:nvSpPr>
-          <p:cNvPr id="6" name="TextBox 5"/>
-          <p:cNvSpPr txBox="1"/>
-          <p:nvPr/>
-        </p:nvSpPr>
-        <p:spPr>
-          <a:xfrm>
-            <a:off x="1143000" y="2560320"/>
-            <a:ext cx="2788920" cy="3291840"/>
+      <p:pic>
+        <p:nvPicPr>
+          <p:cNvPr id="5" name="Picture 4" descr="aws_architecture_diagram.jpg"/>
+          <p:cNvPicPr>
+            <a:picLocks noChangeAspect="1"/>
+          </p:cNvPicPr>
+          <p:nvPr/>
+        </p:nvPicPr>
+        <p:blipFill>
+          <a:blip r:embed="rId2"/>
+          <a:stretch>
+            <a:fillRect/>
+          </a:stretch>
+        </p:blipFill>
+        <p:spPr>
+          <a:xfrm>
+            <a:off x="914400" y="2011680"/>
+            <a:ext cx="10362895" cy="5783941"/>
           </a:xfrm>
           <a:prstGeom prst="rect">
             <a:avLst/>
           </a:prstGeom>
-          <a:noFill/>
-        </p:spPr>
-        <p:txBody>
-          <a:bodyPr wrap="square">
-            <a:spAutoFit/>
-          </a:bodyPr>
-          <a:lstStyle/>
-          <a:p>
-            <a:pPr>
-              <a:spcAft>
-                <a:spcPts val="1200"/>
-              </a:spcAft>
-              <a:defRPr sz="1600" b="1">
-                <a:solidFill>
-                  <a:srgbClr val="06B6D4"/>
-                </a:solidFill>
-                <a:latin typeface="Calibri"/>
-              </a:defRPr>
-            </a:pPr>
-            <a:r>
-              <a:t>Public Subnets (.1.0, .2.0, .3.0)</a:t>
-            </a:r>
-          </a:p>
-          <a:p>
-            <a:pPr>
-              <a:lnSpc>
-                <a:spcPct val="130000"/>
-              </a:lnSpc>
-              <a:defRPr sz="1200">
-                <a:solidFill>
-                  <a:srgbClr val="CBD5E1"/>
-                </a:solidFill>
-                <a:latin typeface="Calibri"/>
-              </a:defRPr>
-            </a:pPr>
-            <a:r>
-              <a:t>Houses Application Load Balancers and 3 redundant NAT Gateways for secure egress.</a:t>
-            </a:r>
-          </a:p>
-        </p:txBody>
-      </p:sp>
-      <p:sp>
-        <p:nvSpPr>
-          <p:cNvPr id="7" name="Rounded Rectangle 6"/>
-          <p:cNvSpPr/>
-          <p:nvPr/>
-        </p:nvSpPr>
-        <p:spPr>
-          <a:xfrm>
-            <a:off x="4480560" y="2286000"/>
-            <a:ext cx="3246120" cy="3840480"/>
-          </a:xfrm>
-          <a:prstGeom prst="roundRect">
-            <a:avLst/>
-          </a:prstGeom>
-          <a:solidFill>
-            <a:srgbClr val="161E31"/>
-          </a:solidFill>
-          <a:ln w="10160">
-            <a:solidFill>
-              <a:srgbClr val="334155"/>
-            </a:solidFill>
-          </a:ln>
-        </p:spPr>
-        <p:style>
-          <a:lnRef idx="1">
-            <a:schemeClr val="accent1"/>
-          </a:lnRef>
-          <a:fillRef idx="3">
-            <a:schemeClr val="accent1"/>
-          </a:fillRef>
-          <a:effectRef idx="2">
-            <a:schemeClr val="accent1"/>
-          </a:effectRef>
-          <a:fontRef idx="minor">
-            <a:schemeClr val="lt1"/>
-          </a:fontRef>
-        </p:style>
-        <p:txBody>
-          <a:bodyPr rtlCol="0" anchor="ctr"/>
-          <a:lstStyle/>
-          <a:p>
-            <a:pPr algn="ctr"/>
-          </a:p>
-        </p:txBody>
-      </p:sp>
-      <p:sp>
-        <p:nvSpPr>
-          <p:cNvPr id="8" name="TextBox 7"/>
-          <p:cNvSpPr txBox="1"/>
-          <p:nvPr/>
-        </p:nvSpPr>
-        <p:spPr>
-          <a:xfrm>
-            <a:off x="4709160" y="2560320"/>
-            <a:ext cx="2788920" cy="3291840"/>
-          </a:xfrm>
-          <a:prstGeom prst="rect">
-            <a:avLst/>
-          </a:prstGeom>
-          <a:noFill/>
-        </p:spPr>
-        <p:txBody>
-          <a:bodyPr wrap="square">
-            <a:spAutoFit/>
-          </a:bodyPr>
-          <a:lstStyle/>
-          <a:p>
-            <a:pPr>
-              <a:spcAft>
-                <a:spcPts val="1200"/>
-              </a:spcAft>
-              <a:defRPr sz="1600" b="1">
-                <a:solidFill>
-                  <a:srgbClr val="F1F5F9"/>
-                </a:solidFill>
-                <a:latin typeface="Calibri"/>
-              </a:defRPr>
-            </a:pPr>
-            <a:r>
-              <a:t>Private App Subnets (.10.0, .20.0, .30.0)</a:t>
-            </a:r>
-          </a:p>
-          <a:p>
-            <a:pPr>
-              <a:lnSpc>
-                <a:spcPct val="130000"/>
-              </a:lnSpc>
-              <a:defRPr sz="1200">
-                <a:solidFill>
-                  <a:srgbClr val="CBD5E1"/>
-                </a:solidFill>
-                <a:latin typeface="Calibri"/>
-              </a:defRPr>
-            </a:pPr>
-            <a:r>
-              <a:t>Houses ECS Fargate tasks and Lambda functions with zero public IP addresses.</a:t>
-            </a:r>
-          </a:p>
-        </p:txBody>
-      </p:sp>
-      <p:sp>
-        <p:nvSpPr>
-          <p:cNvPr id="9" name="Rounded Rectangle 8"/>
-          <p:cNvSpPr/>
-          <p:nvPr/>
-        </p:nvSpPr>
-        <p:spPr>
-          <a:xfrm>
-            <a:off x="8046720" y="2286000"/>
-            <a:ext cx="3246120" cy="3840480"/>
-          </a:xfrm>
-          <a:prstGeom prst="roundRect">
-            <a:avLst/>
-          </a:prstGeom>
-          <a:solidFill>
-            <a:srgbClr val="161E31"/>
-          </a:solidFill>
-          <a:ln w="10160">
-            <a:solidFill>
-              <a:srgbClr val="334155"/>
-            </a:solidFill>
-          </a:ln>
-        </p:spPr>
-        <p:style>
-          <a:lnRef idx="1">
-            <a:schemeClr val="accent1"/>
-          </a:lnRef>
-          <a:fillRef idx="3">
-            <a:schemeClr val="accent1"/>
-          </a:fillRef>
-          <a:effectRef idx="2">
-            <a:schemeClr val="accent1"/>
-          </a:effectRef>
-          <a:fontRef idx="minor">
-            <a:schemeClr val="lt1"/>
-          </a:fontRef>
-        </p:style>
-        <p:txBody>
-          <a:bodyPr rtlCol="0" anchor="ctr"/>
-          <a:lstStyle/>
-          <a:p>
-            <a:pPr algn="ctr"/>
-          </a:p>
-        </p:txBody>
-      </p:sp>
-      <p:sp>
-        <p:nvSpPr>
-          <p:cNvPr id="10" name="TextBox 9"/>
-          <p:cNvSpPr txBox="1"/>
-          <p:nvPr/>
-        </p:nvSpPr>
-        <p:spPr>
-          <a:xfrm>
-            <a:off x="8275320" y="2560320"/>
-            <a:ext cx="2788920" cy="3291840"/>
-          </a:xfrm>
-          <a:prstGeom prst="rect">
-            <a:avLst/>
-          </a:prstGeom>
-          <a:noFill/>
-        </p:spPr>
-        <p:txBody>
-          <a:bodyPr wrap="square">
-            <a:spAutoFit/>
-          </a:bodyPr>
-          <a:lstStyle/>
-          <a:p>
-            <a:pPr>
-              <a:spcAft>
-                <a:spcPts val="1200"/>
-              </a:spcAft>
-              <a:defRPr sz="1600" b="1">
-                <a:solidFill>
-                  <a:srgbClr val="F1F5F9"/>
-                </a:solidFill>
-                <a:latin typeface="Calibri"/>
-              </a:defRPr>
-            </a:pPr>
-            <a:r>
-              <a:t>Isolated DB Subnets (.100.0, .110.0, .120.0)</a:t>
-            </a:r>
-          </a:p>
-          <a:p>
-            <a:pPr>
-              <a:lnSpc>
-                <a:spcPct val="130000"/>
-              </a:lnSpc>
-              <a:defRPr sz="1200">
-                <a:solidFill>
-                  <a:srgbClr val="CBD5E1"/>
-                </a:solidFill>
-                <a:latin typeface="Calibri"/>
-              </a:defRPr>
-            </a:pPr>
-            <a:r>
-              <a:t>Completely isolated from internet; accepts PostgreSQL (5432) strictly from App SG.</a:t>
-            </a:r>
-          </a:p>
-        </p:txBody>
-      </p:sp>
+        </p:spPr>
+      </p:pic>
     </p:spTree>
   </p:cSld>
   <p:clrMapOvr>

</xml_diff>